<commit_message>
docs: replace deck concept art with deployed screenshots
Co-Authored-By: Claude Code <noreply@anthropic.com>
</commit_message>
<xml_diff>
--- a/docs/元宇宙商圈_课程汇报.pptx
+++ b/docs/元宇宙商圈_课程汇报.pptx
@@ -513,7 +513,7 @@
           <a:lstStyle/>
           <a:p>
             <a:r>
-              <a:t>开场（20秒）：各位老师好，我们做的是 ERP 课程题目 1.7 元宇宙商圈。这版是 v2 精简版，重点不是堆电商功能，而是把“多个服装工厂的 3D 店铺 + 自动建店 + 下单/优惠券”做成一个能现场演示的闭环。右边是概念示意，开发后会替换成实机截图。</a:t>
+              <a:t>开场（20秒）：各位老师好，我们做的是 ERP 课程题目 1.7 元宇宙商圈。这版是 v2 精简版，重点不是堆电商功能，而是把“多个服装工厂的 3D 店铺 + 自动建店 + 下单/优惠券”做成一个能现场演示的闭环。右边是当前部署版本的实机截图。</a:t>
             </a:r>
           </a:p>
         </p:txBody>
@@ -13028,7 +13028,7 @@
                 </a:solidFill>
                 <a:latin typeface="微软雅黑"/>
               </a:rPr>
-              <a:t>概念示意 · 开发后替换为实机截图</a:t>
+              <a:t>实机截图 · 2026-10-20 · 1920×1080 视口</a:t>
             </a:r>
           </a:p>
         </p:txBody>
@@ -13952,7 +13952,7 @@
                 </a:solidFill>
                 <a:latin typeface="微软雅黑"/>
               </a:rPr>
-              <a:t>概念示意 · 开发后替换为实机截图</a:t>
+              <a:t>实机截图 · 建店器实时 3D 预览</a:t>
             </a:r>
           </a:p>
         </p:txBody>

</xml_diff>